<commit_message>
Fill in investor ask slide: RM10M to RM10M ARR in 36 months
Replace the ask-slide placeholders with the raise (RM10M, approx US$2.5M),
milestone (RM10M ARR), timeframe (36 months), and the 45/35/12/8 use-of-funds
split.
</commit_message>
<xml_diff>
--- a/docs/aster-investor.pptx
+++ b/docs/aster-investor.pptx
@@ -7309,7 +7309,7 @@
         </p:nvSpPr>
         <p:spPr>
           <a:xfrm>
-            <a:off x="777240" y="2331720"/>
+            <a:off x="777240" y="2286000"/>
             <a:ext cx="3108960" cy="274320"/>
           </a:xfrm>
           <a:prstGeom prst="rect">
@@ -7348,24 +7348,24 @@
         </p:nvSpPr>
         <p:spPr>
           <a:xfrm>
-            <a:off x="777240" y="2697480"/>
-            <a:ext cx="3108960" cy="731520"/>
-          </a:xfrm>
-          <a:prstGeom prst="rect">
-            <a:avLst/>
-          </a:prstGeom>
-          <a:noFill/>
-          <a:ln/>
-        </p:spPr>
-        <p:txBody>
-          <a:bodyPr wrap="square" lIns="0" tIns="0" rIns="0" bIns="0" rtlCol="0" anchor="ctr"/>
-          <a:lstStyle/>
-          <a:p>
-            <a:pPr algn="l" indent="0" marL="0">
-              <a:buNone/>
-            </a:pPr>
-            <a:r>
-              <a:rPr lang="en-US" sz="3400" b="1" dirty="0">
+            <a:off x="777240" y="2615184"/>
+            <a:ext cx="3108960" cy="685800"/>
+          </a:xfrm>
+          <a:prstGeom prst="rect">
+            <a:avLst/>
+          </a:prstGeom>
+          <a:noFill/>
+          <a:ln/>
+        </p:spPr>
+        <p:txBody>
+          <a:bodyPr wrap="square" lIns="0" tIns="0" rIns="0" bIns="0" rtlCol="0" anchor="ctr"/>
+          <a:lstStyle/>
+          <a:p>
+            <a:pPr algn="l" indent="0" marL="0">
+              <a:buNone/>
+            </a:pPr>
+            <a:r>
+              <a:rPr lang="en-US" sz="3600" b="1" dirty="0">
                 <a:solidFill>
                   <a:srgbClr val="FFFFFF"/>
                 </a:solidFill>
@@ -7373,9 +7373,9 @@
                 <a:ea typeface="Calibri" pitchFamily="34" charset="-122"/>
                 <a:cs typeface="Calibri" pitchFamily="34" charset="-120"/>
               </a:rPr>
-              <a:t>[ amount ]</a:t>
-            </a:r>
-            <a:endParaRPr lang="en-US" sz="3400" dirty="0"/>
+              <a:t>RM10M</a:t>
+            </a:r>
+            <a:endParaRPr lang="en-US" sz="3600" dirty="0"/>
           </a:p>
         </p:txBody>
       </p:sp>
@@ -7387,24 +7387,24 @@
         </p:nvSpPr>
         <p:spPr>
           <a:xfrm>
-            <a:off x="777240" y="3474720"/>
-            <a:ext cx="3108960" cy="731520"/>
-          </a:xfrm>
-          <a:prstGeom prst="rect">
-            <a:avLst/>
-          </a:prstGeom>
-          <a:noFill/>
-          <a:ln/>
-        </p:spPr>
-        <p:txBody>
-          <a:bodyPr wrap="square" lIns="0" tIns="0" rIns="0" bIns="0" rtlCol="0" anchor="ctr"/>
-          <a:lstStyle/>
-          <a:p>
-            <a:pPr algn="l" indent="0" marL="0">
-              <a:buNone/>
-            </a:pPr>
-            <a:r>
-              <a:rPr lang="en-US" sz="1200" i="1" dirty="0">
+            <a:off x="777240" y="3346704"/>
+            <a:ext cx="3108960" cy="292608"/>
+          </a:xfrm>
+          <a:prstGeom prst="rect">
+            <a:avLst/>
+          </a:prstGeom>
+          <a:noFill/>
+          <a:ln/>
+        </p:spPr>
+        <p:txBody>
+          <a:bodyPr wrap="square" lIns="0" tIns="0" rIns="0" bIns="0" rtlCol="0" anchor="ctr"/>
+          <a:lstStyle/>
+          <a:p>
+            <a:pPr algn="l" indent="0" marL="0">
+              <a:buNone/>
+            </a:pPr>
+            <a:r>
+              <a:rPr lang="en-US" sz="1300" b="1" dirty="0">
                 <a:solidFill>
                   <a:srgbClr val="CADCFC"/>
                 </a:solidFill>
@@ -7412,15 +7412,54 @@
                 <a:ea typeface="Calibri" pitchFamily="34" charset="-122"/>
                 <a:cs typeface="Calibri" pitchFamily="34" charset="-120"/>
               </a:rPr>
-              <a:t>to reach [ milestone: e.g. RMx ARR / N logos ] in [ N ] months.</a:t>
-            </a:r>
-            <a:endParaRPr lang="en-US" sz="1200" dirty="0"/>
+              <a:t>≈ US$2.5M</a:t>
+            </a:r>
+            <a:endParaRPr lang="en-US" sz="1300" dirty="0"/>
           </a:p>
         </p:txBody>
       </p:sp>
       <p:sp>
         <p:nvSpPr>
           <p:cNvPr id="9" name="Text 7"/>
+          <p:cNvSpPr/>
+          <p:nvPr/>
+        </p:nvSpPr>
+        <p:spPr>
+          <a:xfrm>
+            <a:off x="777240" y="3675888"/>
+            <a:ext cx="3108960" cy="548640"/>
+          </a:xfrm>
+          <a:prstGeom prst="rect">
+            <a:avLst/>
+          </a:prstGeom>
+          <a:noFill/>
+          <a:ln/>
+        </p:spPr>
+        <p:txBody>
+          <a:bodyPr wrap="square" lIns="0" tIns="0" rIns="0" bIns="0" rtlCol="0" anchor="ctr"/>
+          <a:lstStyle/>
+          <a:p>
+            <a:pPr algn="l" indent="0" marL="0">
+              <a:buNone/>
+            </a:pPr>
+            <a:r>
+              <a:rPr lang="en-US" sz="1250" i="1" dirty="0">
+                <a:solidFill>
+                  <a:srgbClr val="CADCFC"/>
+                </a:solidFill>
+                <a:latin typeface="Calibri" pitchFamily="34" charset="0"/>
+                <a:ea typeface="Calibri" pitchFamily="34" charset="-122"/>
+                <a:cs typeface="Calibri" pitchFamily="34" charset="-120"/>
+              </a:rPr>
+              <a:t>to reach RM10M ARR in 36 months.</a:t>
+            </a:r>
+            <a:endParaRPr lang="en-US" sz="1250" dirty="0"/>
+          </a:p>
+        </p:txBody>
+      </p:sp>
+      <p:sp>
+        <p:nvSpPr>
+          <p:cNvPr id="10" name="Text 8"/>
           <p:cNvSpPr/>
           <p:nvPr/>
         </p:nvSpPr>
@@ -7459,7 +7498,7 @@
       </p:sp>
       <p:sp>
         <p:nvSpPr>
-          <p:cNvPr id="10" name="Shape 8"/>
+          <p:cNvPr id="11" name="Shape 9"/>
           <p:cNvSpPr/>
           <p:nvPr/>
         </p:nvSpPr>
@@ -7483,7 +7522,7 @@
       </p:sp>
       <p:sp>
         <p:nvSpPr>
-          <p:cNvPr id="11" name="Text 9"/>
+          <p:cNvPr id="12" name="Text 10"/>
           <p:cNvSpPr/>
           <p:nvPr/>
         </p:nvSpPr>
@@ -7522,7 +7561,7 @@
       </p:sp>
       <p:sp>
         <p:nvSpPr>
-          <p:cNvPr id="12" name="Text 10"/>
+          <p:cNvPr id="13" name="Text 11"/>
           <p:cNvSpPr/>
           <p:nvPr/>
         </p:nvSpPr>
@@ -7561,7 +7600,7 @@
       </p:sp>
       <p:sp>
         <p:nvSpPr>
-          <p:cNvPr id="13" name="Text 11"/>
+          <p:cNvPr id="14" name="Text 12"/>
           <p:cNvSpPr/>
           <p:nvPr/>
         </p:nvSpPr>
@@ -7600,7 +7639,7 @@
       </p:sp>
       <p:sp>
         <p:nvSpPr>
-          <p:cNvPr id="14" name="Shape 12"/>
+          <p:cNvPr id="15" name="Shape 13"/>
           <p:cNvSpPr/>
           <p:nvPr/>
         </p:nvSpPr>
@@ -7624,7 +7663,7 @@
       </p:sp>
       <p:sp>
         <p:nvSpPr>
-          <p:cNvPr id="15" name="Text 13"/>
+          <p:cNvPr id="16" name="Text 14"/>
           <p:cNvSpPr/>
           <p:nvPr/>
         </p:nvSpPr>
@@ -7663,7 +7702,7 @@
       </p:sp>
       <p:sp>
         <p:nvSpPr>
-          <p:cNvPr id="16" name="Text 14"/>
+          <p:cNvPr id="17" name="Text 15"/>
           <p:cNvSpPr/>
           <p:nvPr/>
         </p:nvSpPr>
@@ -7702,7 +7741,7 @@
       </p:sp>
       <p:sp>
         <p:nvSpPr>
-          <p:cNvPr id="17" name="Text 15"/>
+          <p:cNvPr id="18" name="Text 16"/>
           <p:cNvSpPr/>
           <p:nvPr/>
         </p:nvSpPr>
@@ -7741,7 +7780,7 @@
       </p:sp>
       <p:sp>
         <p:nvSpPr>
-          <p:cNvPr id="18" name="Shape 16"/>
+          <p:cNvPr id="19" name="Shape 17"/>
           <p:cNvSpPr/>
           <p:nvPr/>
         </p:nvSpPr>
@@ -7765,7 +7804,7 @@
       </p:sp>
       <p:sp>
         <p:nvSpPr>
-          <p:cNvPr id="19" name="Text 17"/>
+          <p:cNvPr id="20" name="Text 18"/>
           <p:cNvSpPr/>
           <p:nvPr/>
         </p:nvSpPr>
@@ -7804,7 +7843,7 @@
       </p:sp>
       <p:sp>
         <p:nvSpPr>
-          <p:cNvPr id="20" name="Text 18"/>
+          <p:cNvPr id="21" name="Text 19"/>
           <p:cNvSpPr/>
           <p:nvPr/>
         </p:nvSpPr>
@@ -7843,7 +7882,7 @@
       </p:sp>
       <p:sp>
         <p:nvSpPr>
-          <p:cNvPr id="21" name="Text 19"/>
+          <p:cNvPr id="22" name="Text 20"/>
           <p:cNvSpPr/>
           <p:nvPr/>
         </p:nvSpPr>
@@ -7882,7 +7921,7 @@
       </p:sp>
       <p:sp>
         <p:nvSpPr>
-          <p:cNvPr id="22" name="Shape 20"/>
+          <p:cNvPr id="23" name="Shape 21"/>
           <p:cNvSpPr/>
           <p:nvPr/>
         </p:nvSpPr>
@@ -7906,7 +7945,7 @@
       </p:sp>
       <p:sp>
         <p:nvSpPr>
-          <p:cNvPr id="23" name="Text 21"/>
+          <p:cNvPr id="24" name="Text 22"/>
           <p:cNvSpPr/>
           <p:nvPr/>
         </p:nvSpPr>
@@ -7945,7 +7984,7 @@
       </p:sp>
       <p:sp>
         <p:nvSpPr>
-          <p:cNvPr id="24" name="Text 22"/>
+          <p:cNvPr id="25" name="Text 23"/>
           <p:cNvSpPr/>
           <p:nvPr/>
         </p:nvSpPr>
@@ -7984,7 +8023,7 @@
       </p:sp>
       <p:sp>
         <p:nvSpPr>
-          <p:cNvPr id="25" name="Text 23"/>
+          <p:cNvPr id="26" name="Text 24"/>
           <p:cNvSpPr/>
           <p:nvPr/>
         </p:nvSpPr>
@@ -8023,7 +8062,7 @@
       </p:sp>
       <p:sp>
         <p:nvSpPr>
-          <p:cNvPr id="26" name="Text 24"/>
+          <p:cNvPr id="27" name="Text 25"/>
           <p:cNvSpPr/>
           <p:nvPr/>
         </p:nvSpPr>
@@ -8054,7 +8093,7 @@
                 <a:ea typeface="Calibri" pitchFamily="34" charset="-122"/>
                 <a:cs typeface="Calibri" pitchFamily="34" charset="-120"/>
               </a:rPr>
-              <a:t>Bracketed figures are placeholders. Set the raise amount, milestone and allocation to your plan.</a:t>
+              <a:t>Raising RM10M (≈ US$2.5M) to reach RM10M ARR within 36 months. Allocation is indicative and adjusts with the plan.</a:t>
             </a:r>
             <a:endParaRPr lang="en-US" sz="950" dirty="0"/>
           </a:p>
@@ -8062,7 +8101,7 @@
       </p:sp>
       <p:sp>
         <p:nvSpPr>
-          <p:cNvPr id="27" name="Text 25"/>
+          <p:cNvPr id="28" name="Text 26"/>
           <p:cNvSpPr/>
           <p:nvPr/>
         </p:nvSpPr>
@@ -8101,7 +8140,7 @@
       </p:sp>
       <p:sp>
         <p:nvSpPr>
-          <p:cNvPr id="28" name="Text 26"/>
+          <p:cNvPr id="29" name="Text 27"/>
           <p:cNvSpPr/>
           <p:nvPr/>
         </p:nvSpPr>

</xml_diff>